<commit_message>
Fix the two false statements on slide 6 of the deck
"bash is gone / Removed from the tool list, so the model does not even try"
is not what the software does. scripts/launch.sh passes bash in --tools and
decideShell allows it for a cleared provider inside the container. The slide
now says "bash is contained" and describes the container boundary, which is
the claim the code supports and the one the limits line already implies.

The status line on the same slide ended "session public". index.ts sets the
session level to the workspace label, so on a restricted workspace it reads
"session restricted" and carries the withheld marker. Corrected, and recoloured
from the green used for public to the red used elsewhere for restricted.

The pptx text was edited in place and the PDF re-exported with LibreOffice.
Checked at 80 dpi: pages 1-5 and 7-9 are pixel-identical to the committed PDF,
and page 6 differs only inside the region that was edited.
</commit_message>
<xml_diff>
--- a/demo/Norrin_Pitch.pptx
+++ b/demo/Norrin_Pitch.pptx
@@ -4690,13 +4690,13 @@
             <a:r>
               <a:rPr lang="en-US" sz="1000" b="1" dirty="0">
                 <a:solidFill>
-                  <a:srgbClr val="00703C"/>
+                  <a:srgbClr val="C8102E"/>
                 </a:solidFill>
                 <a:latin typeface="Courier New" pitchFamily="34" charset="0"/>
                 <a:ea typeface="Courier New" pitchFamily="34" charset="-122"/>
                 <a:cs typeface="Courier New" pitchFamily="34" charset="-120"/>
               </a:rPr>
-              <a:t>public</a:t>
+              <a:t>restricted  ⛔ messages withheld</a:t>
             </a:r>
             <a:endParaRPr lang="en-US" sz="1000" dirty="0"/>
           </a:p>
@@ -4822,7 +4822,7 @@
                 <a:ea typeface="Cambria" pitchFamily="34" charset="-122"/>
                 <a:cs typeface="Cambria" pitchFamily="34" charset="-120"/>
               </a:rPr>
-              <a:t>bash is gone</a:t>
+              <a:t>bash is contained</a:t>
             </a:r>
             <a:endParaRPr lang="en-US" sz="1400" dirty="0"/>
           </a:p>
@@ -4864,7 +4864,7 @@
                 <a:ea typeface="Cambria" pitchFamily="34" charset="-122"/>
                 <a:cs typeface="Cambria" pitchFamily="34" charset="-120"/>
               </a:rPr>
-              <a:t>Removed from the tool list, so the model does not even try, and refused if it does.</a:t>
+              <a:t>It runs only inside the launcher’s container, where the workspace is the only writable folder, and only for a cleared provider.</a:t>
             </a:r>
             <a:endParaRPr lang="en-US" sz="1250" dirty="0"/>
           </a:p>

</xml_diff>

<commit_message>
Add VERDA to the cleared bands, drop OPENAI from confidential
The deck and the Pages cover listed the wrong providers. Per
.pi/confidentiality.json, verda holds confidential clearance and openai
only public, so the confidential band now reads MISTRAL, VERDA,
LEMONADE, OLLAMA and the public band gains VERDA.
</commit_message>
<xml_diff>
--- a/demo/Norrin_Pitch.pptx
+++ b/demo/Norrin_Pitch.pptx
@@ -1674,7 +1674,7 @@
                 <a:ea typeface="Arial" pitchFamily="34" charset="-122"/>
                 <a:cs typeface="Arial" pitchFamily="34" charset="-120"/>
               </a:rPr>
-              <a:t>CONFIDENTIAL  //  CLEARED: OPENAI, MISTRAL, LEMONADE, OLLAMA</a:t>
+              <a:t>CONFIDENTIAL  //  CLEARED: MISTRAL, VERDA, LEMONADE, OLLAMA</a:t>
             </a:r>
             <a:endParaRPr lang="en-US" sz="900" dirty="0"/>
           </a:p>
@@ -1742,7 +1742,7 @@
                 <a:ea typeface="Arial" pitchFamily="34" charset="-122"/>
                 <a:cs typeface="Arial" pitchFamily="34" charset="-120"/>
               </a:rPr>
-              <a:t>CONFIDENTIAL  //  CLEARED: OPENAI, MISTRAL, LEMONADE, OLLAMA</a:t>
+              <a:t>CONFIDENTIAL  //  CLEARED: MISTRAL, VERDA, LEMONADE, OLLAMA</a:t>
             </a:r>
             <a:endParaRPr lang="en-US" sz="900" dirty="0"/>
           </a:p>
@@ -1947,7 +1947,7 @@
                 <a:ea typeface="Arial" pitchFamily="34" charset="-122"/>
                 <a:cs typeface="Arial" pitchFamily="34" charset="-120"/>
               </a:rPr>
-              <a:t>CONFIDENTIAL  //  CLEARED: OPENAI, MISTRAL, LEMONADE, OLLAMA</a:t>
+              <a:t>CONFIDENTIAL  //  CLEARED: MISTRAL, VERDA, LEMONADE, OLLAMA</a:t>
             </a:r>
             <a:endParaRPr lang="en-US" sz="900" dirty="0"/>
           </a:p>
@@ -2015,7 +2015,7 @@
                 <a:ea typeface="Arial" pitchFamily="34" charset="-122"/>
                 <a:cs typeface="Arial" pitchFamily="34" charset="-120"/>
               </a:rPr>
-              <a:t>CONFIDENTIAL  //  CLEARED: OPENAI, MISTRAL, LEMONADE, OLLAMA</a:t>
+              <a:t>CONFIDENTIAL  //  CLEARED: MISTRAL, VERDA, LEMONADE, OLLAMA</a:t>
             </a:r>
             <a:endParaRPr lang="en-US" sz="900" dirty="0"/>
           </a:p>
@@ -2799,7 +2799,7 @@
                 <a:ea typeface="Arial" pitchFamily="34" charset="-122"/>
                 <a:cs typeface="Arial" pitchFamily="34" charset="-120"/>
               </a:rPr>
-              <a:t>PUBLIC  //  CLEARED: GOOGLE, OPENAI, MISTRAL, LEMONADE, OLLAMA</a:t>
+              <a:t>PUBLIC  //  CLEARED: GOOGLE, OPENAI, MISTRAL, VERDA, LEMONADE, OLLAMA</a:t>
             </a:r>
             <a:endParaRPr lang="en-US" sz="900" dirty="0"/>
           </a:p>
@@ -2867,7 +2867,7 @@
                 <a:ea typeface="Arial" pitchFamily="34" charset="-122"/>
                 <a:cs typeface="Arial" pitchFamily="34" charset="-120"/>
               </a:rPr>
-              <a:t>PUBLIC  //  CLEARED: GOOGLE, OPENAI, MISTRAL, LEMONADE, OLLAMA</a:t>
+              <a:t>PUBLIC  //  CLEARED: GOOGLE, OPENAI, MISTRAL, VERDA, LEMONADE, OLLAMA</a:t>
             </a:r>
             <a:endParaRPr lang="en-US" sz="900" dirty="0"/>
           </a:p>
@@ -3352,7 +3352,7 @@
                 <a:ea typeface="Arial" pitchFamily="34" charset="-122"/>
                 <a:cs typeface="Arial" pitchFamily="34" charset="-120"/>
               </a:rPr>
-              <a:t>CONFIDENTIAL  //  CLEARED: OPENAI, MISTRAL, LEMONADE, OLLAMA</a:t>
+              <a:t>CONFIDENTIAL  //  CLEARED: MISTRAL, VERDA, LEMONADE, OLLAMA</a:t>
             </a:r>
             <a:endParaRPr lang="en-US" sz="900" dirty="0"/>
           </a:p>
@@ -3420,7 +3420,7 @@
                 <a:ea typeface="Arial" pitchFamily="34" charset="-122"/>
                 <a:cs typeface="Arial" pitchFamily="34" charset="-120"/>
               </a:rPr>
-              <a:t>CONFIDENTIAL  //  CLEARED: OPENAI, MISTRAL, LEMONADE, OLLAMA</a:t>
+              <a:t>CONFIDENTIAL  //  CLEARED: MISTRAL, VERDA, LEMONADE, OLLAMA</a:t>
             </a:r>
             <a:endParaRPr lang="en-US" sz="900" dirty="0"/>
           </a:p>
@@ -3873,7 +3873,7 @@
                 <a:ea typeface="Arial" pitchFamily="34" charset="-122"/>
                 <a:cs typeface="Arial" pitchFamily="34" charset="-120"/>
               </a:rPr>
-              <a:t>CONFIDENTIAL  //  CLEARED: OPENAI, MISTRAL, LEMONADE, OLLAMA</a:t>
+              <a:t>CONFIDENTIAL  //  CLEARED: MISTRAL, VERDA, LEMONADE, OLLAMA</a:t>
             </a:r>
             <a:endParaRPr lang="en-US" sz="900" dirty="0"/>
           </a:p>
@@ -3941,7 +3941,7 @@
                 <a:ea typeface="Arial" pitchFamily="34" charset="-122"/>
                 <a:cs typeface="Arial" pitchFamily="34" charset="-120"/>
               </a:rPr>
-              <a:t>CONFIDENTIAL  //  CLEARED: OPENAI, MISTRAL, LEMONADE, OLLAMA</a:t>
+              <a:t>CONFIDENTIAL  //  CLEARED: MISTRAL, VERDA, LEMONADE, OLLAMA</a:t>
             </a:r>
             <a:endParaRPr lang="en-US" sz="900" dirty="0"/>
           </a:p>
@@ -5035,7 +5035,7 @@
                 <a:ea typeface="Arial" pitchFamily="34" charset="-122"/>
                 <a:cs typeface="Arial" pitchFamily="34" charset="-120"/>
               </a:rPr>
-              <a:t>PUBLIC  //  CLEARED: GOOGLE, OPENAI, MISTRAL, LEMONADE, OLLAMA</a:t>
+              <a:t>PUBLIC  //  CLEARED: GOOGLE, OPENAI, MISTRAL, VERDA, LEMONADE, OLLAMA</a:t>
             </a:r>
             <a:endParaRPr lang="en-US" sz="900" dirty="0"/>
           </a:p>
@@ -5103,7 +5103,7 @@
                 <a:ea typeface="Arial" pitchFamily="34" charset="-122"/>
                 <a:cs typeface="Arial" pitchFamily="34" charset="-120"/>
               </a:rPr>
-              <a:t>PUBLIC  //  CLEARED: GOOGLE, OPENAI, MISTRAL, LEMONADE, OLLAMA</a:t>
+              <a:t>PUBLIC  //  CLEARED: GOOGLE, OPENAI, MISTRAL, VERDA, LEMONADE, OLLAMA</a:t>
             </a:r>
             <a:endParaRPr lang="en-US" sz="900" dirty="0"/>
           </a:p>
@@ -5665,7 +5665,7 @@
                 <a:ea typeface="Arial" pitchFamily="34" charset="-122"/>
                 <a:cs typeface="Arial" pitchFamily="34" charset="-120"/>
               </a:rPr>
-              <a:t>PUBLIC  //  CLEARED: GOOGLE, OPENAI, MISTRAL, LEMONADE, OLLAMA</a:t>
+              <a:t>PUBLIC  //  CLEARED: GOOGLE, OPENAI, MISTRAL, VERDA, LEMONADE, OLLAMA</a:t>
             </a:r>
             <a:endParaRPr lang="en-US" sz="900" dirty="0"/>
           </a:p>
@@ -5733,7 +5733,7 @@
                 <a:ea typeface="Arial" pitchFamily="34" charset="-122"/>
                 <a:cs typeface="Arial" pitchFamily="34" charset="-120"/>
               </a:rPr>
-              <a:t>PUBLIC  //  CLEARED: GOOGLE, OPENAI, MISTRAL, LEMONADE, OLLAMA</a:t>
+              <a:t>PUBLIC  //  CLEARED: GOOGLE, OPENAI, MISTRAL, VERDA, LEMONADE, OLLAMA</a:t>
             </a:r>
             <a:endParaRPr lang="en-US" sz="900" dirty="0"/>
           </a:p>
@@ -5969,7 +5969,7 @@
                 <a:ea typeface="Cambria" pitchFamily="34" charset="-122"/>
                 <a:cs typeface="Cambria" pitchFamily="34" charset="-120"/>
               </a:rPr>
-              <a:t>Instrument faults reported separately in 11 of the 18 files</a:t>
+              <a:t>Instrument faults reported separately in 12 of the 18 files</a:t>
             </a:r>
             <a:endParaRPr lang="en-US" sz="1200" dirty="0"/>
           </a:p>
@@ -6308,7 +6308,7 @@
                 <a:ea typeface="Cambria" pitchFamily="34" charset="-122"/>
                 <a:cs typeface="Cambria" pitchFamily="34" charset="-120"/>
               </a:rPr>
-              <a:t>About 20 tags marked indeterminate, with confidences stated</a:t>
+              <a:t>27 tags marked indeterminate, with confidences stated</a:t>
             </a:r>
             <a:endParaRPr lang="en-US" sz="1200" dirty="0"/>
           </a:p>
@@ -6634,7 +6634,7 @@
                 <a:ea typeface="Arial" pitchFamily="34" charset="-122"/>
                 <a:cs typeface="Arial" pitchFamily="34" charset="-120"/>
               </a:rPr>
-              <a:t>PUBLIC  //  CLEARED: GOOGLE, OPENAI, MISTRAL, LEMONADE, OLLAMA</a:t>
+              <a:t>PUBLIC  //  CLEARED: GOOGLE, OPENAI, MISTRAL, VERDA, LEMONADE, OLLAMA</a:t>
             </a:r>
             <a:endParaRPr lang="en-US" sz="900" dirty="0"/>
           </a:p>
@@ -6702,7 +6702,7 @@
                 <a:ea typeface="Arial" pitchFamily="34" charset="-122"/>
                 <a:cs typeface="Arial" pitchFamily="34" charset="-120"/>
               </a:rPr>
-              <a:t>PUBLIC  //  CLEARED: GOOGLE, OPENAI, MISTRAL, LEMONADE, OLLAMA</a:t>
+              <a:t>PUBLIC  //  CLEARED: GOOGLE, OPENAI, MISTRAL, VERDA, LEMONADE, OLLAMA</a:t>
             </a:r>
             <a:endParaRPr lang="en-US" sz="900" dirty="0"/>
           </a:p>

</xml_diff>